<commit_message>
Minor fix in the plotting code
</commit_message>
<xml_diff>
--- a/Ivan/MPC_RL_Cartpole/Results/Results.pptx
+++ b/Ivan/MPC_RL_Cartpole/Results/Results.pptx
@@ -265,7 +265,7 @@
           <a:p>
             <a:fld id="{877FD08C-8E7C-43AB-85E3-AC16F23677BF}" type="datetimeFigureOut">
               <a:rPr lang="en-US" smtClean="0"/>
-              <a:t>3/27/2025</a:t>
+              <a:t>4/2/2025</a:t>
             </a:fld>
             <a:endParaRPr lang="en-US"/>
           </a:p>
@@ -463,7 +463,7 @@
           <a:p>
             <a:fld id="{877FD08C-8E7C-43AB-85E3-AC16F23677BF}" type="datetimeFigureOut">
               <a:rPr lang="en-US" smtClean="0"/>
-              <a:t>3/27/2025</a:t>
+              <a:t>4/2/2025</a:t>
             </a:fld>
             <a:endParaRPr lang="en-US"/>
           </a:p>
@@ -671,7 +671,7 @@
           <a:p>
             <a:fld id="{877FD08C-8E7C-43AB-85E3-AC16F23677BF}" type="datetimeFigureOut">
               <a:rPr lang="en-US" smtClean="0"/>
-              <a:t>3/27/2025</a:t>
+              <a:t>4/2/2025</a:t>
             </a:fld>
             <a:endParaRPr lang="en-US"/>
           </a:p>
@@ -869,7 +869,7 @@
           <a:p>
             <a:fld id="{877FD08C-8E7C-43AB-85E3-AC16F23677BF}" type="datetimeFigureOut">
               <a:rPr lang="en-US" smtClean="0"/>
-              <a:t>3/27/2025</a:t>
+              <a:t>4/2/2025</a:t>
             </a:fld>
             <a:endParaRPr lang="en-US"/>
           </a:p>
@@ -1144,7 +1144,7 @@
           <a:p>
             <a:fld id="{877FD08C-8E7C-43AB-85E3-AC16F23677BF}" type="datetimeFigureOut">
               <a:rPr lang="en-US" smtClean="0"/>
-              <a:t>3/27/2025</a:t>
+              <a:t>4/2/2025</a:t>
             </a:fld>
             <a:endParaRPr lang="en-US"/>
           </a:p>
@@ -1409,7 +1409,7 @@
           <a:p>
             <a:fld id="{877FD08C-8E7C-43AB-85E3-AC16F23677BF}" type="datetimeFigureOut">
               <a:rPr lang="en-US" smtClean="0"/>
-              <a:t>3/27/2025</a:t>
+              <a:t>4/2/2025</a:t>
             </a:fld>
             <a:endParaRPr lang="en-US"/>
           </a:p>
@@ -1821,7 +1821,7 @@
           <a:p>
             <a:fld id="{877FD08C-8E7C-43AB-85E3-AC16F23677BF}" type="datetimeFigureOut">
               <a:rPr lang="en-US" smtClean="0"/>
-              <a:t>3/27/2025</a:t>
+              <a:t>4/2/2025</a:t>
             </a:fld>
             <a:endParaRPr lang="en-US"/>
           </a:p>
@@ -1962,7 +1962,7 @@
           <a:p>
             <a:fld id="{877FD08C-8E7C-43AB-85E3-AC16F23677BF}" type="datetimeFigureOut">
               <a:rPr lang="en-US" smtClean="0"/>
-              <a:t>3/27/2025</a:t>
+              <a:t>4/2/2025</a:t>
             </a:fld>
             <a:endParaRPr lang="en-US"/>
           </a:p>
@@ -2075,7 +2075,7 @@
           <a:p>
             <a:fld id="{877FD08C-8E7C-43AB-85E3-AC16F23677BF}" type="datetimeFigureOut">
               <a:rPr lang="en-US" smtClean="0"/>
-              <a:t>3/27/2025</a:t>
+              <a:t>4/2/2025</a:t>
             </a:fld>
             <a:endParaRPr lang="en-US"/>
           </a:p>
@@ -2386,7 +2386,7 @@
           <a:p>
             <a:fld id="{877FD08C-8E7C-43AB-85E3-AC16F23677BF}" type="datetimeFigureOut">
               <a:rPr lang="en-US" smtClean="0"/>
-              <a:t>3/27/2025</a:t>
+              <a:t>4/2/2025</a:t>
             </a:fld>
             <a:endParaRPr lang="en-US"/>
           </a:p>
@@ -2674,7 +2674,7 @@
           <a:p>
             <a:fld id="{877FD08C-8E7C-43AB-85E3-AC16F23677BF}" type="datetimeFigureOut">
               <a:rPr lang="en-US" smtClean="0"/>
-              <a:t>3/27/2025</a:t>
+              <a:t>4/2/2025</a:t>
             </a:fld>
             <a:endParaRPr lang="en-US"/>
           </a:p>
@@ -2915,7 +2915,7 @@
           <a:p>
             <a:fld id="{877FD08C-8E7C-43AB-85E3-AC16F23677BF}" type="datetimeFigureOut">
               <a:rPr lang="en-US" smtClean="0"/>
-              <a:t>3/27/2025</a:t>
+              <a:t>4/2/2025</a:t>
             </a:fld>
             <a:endParaRPr lang="en-US"/>
           </a:p>

</xml_diff>

<commit_message>
Added the error measures and improved the overall code
</commit_message>
<xml_diff>
--- a/Ivan/MPC_RL_Cartpole/Results/Results.pptx
+++ b/Ivan/MPC_RL_Cartpole/Results/Results.pptx
@@ -10,9 +10,13 @@
     <p:sldId id="263" r:id="rId4"/>
     <p:sldId id="257" r:id="rId5"/>
     <p:sldId id="261" r:id="rId6"/>
-    <p:sldId id="259" r:id="rId7"/>
-    <p:sldId id="260" r:id="rId8"/>
-    <p:sldId id="264" r:id="rId9"/>
+    <p:sldId id="260" r:id="rId7"/>
+    <p:sldId id="264" r:id="rId8"/>
+    <p:sldId id="265" r:id="rId9"/>
+    <p:sldId id="266" r:id="rId10"/>
+    <p:sldId id="267" r:id="rId11"/>
+    <p:sldId id="268" r:id="rId12"/>
+    <p:sldId id="269" r:id="rId13"/>
   </p:sldIdLst>
   <p:sldSz cx="12192000" cy="6858000"/>
   <p:notesSz cx="6858000" cy="9144000"/>
@@ -266,7 +270,7 @@
           <a:p>
             <a:fld id="{877FD08C-8E7C-43AB-85E3-AC16F23677BF}" type="datetimeFigureOut">
               <a:rPr lang="en-US" smtClean="0"/>
-              <a:t>4/2/2025</a:t>
+              <a:t>4/30/2025</a:t>
             </a:fld>
             <a:endParaRPr lang="en-US"/>
           </a:p>
@@ -464,7 +468,7 @@
           <a:p>
             <a:fld id="{877FD08C-8E7C-43AB-85E3-AC16F23677BF}" type="datetimeFigureOut">
               <a:rPr lang="en-US" smtClean="0"/>
-              <a:t>4/2/2025</a:t>
+              <a:t>4/30/2025</a:t>
             </a:fld>
             <a:endParaRPr lang="en-US"/>
           </a:p>
@@ -672,7 +676,7 @@
           <a:p>
             <a:fld id="{877FD08C-8E7C-43AB-85E3-AC16F23677BF}" type="datetimeFigureOut">
               <a:rPr lang="en-US" smtClean="0"/>
-              <a:t>4/2/2025</a:t>
+              <a:t>4/30/2025</a:t>
             </a:fld>
             <a:endParaRPr lang="en-US"/>
           </a:p>
@@ -870,7 +874,7 @@
           <a:p>
             <a:fld id="{877FD08C-8E7C-43AB-85E3-AC16F23677BF}" type="datetimeFigureOut">
               <a:rPr lang="en-US" smtClean="0"/>
-              <a:t>4/2/2025</a:t>
+              <a:t>4/30/2025</a:t>
             </a:fld>
             <a:endParaRPr lang="en-US"/>
           </a:p>
@@ -1145,7 +1149,7 @@
           <a:p>
             <a:fld id="{877FD08C-8E7C-43AB-85E3-AC16F23677BF}" type="datetimeFigureOut">
               <a:rPr lang="en-US" smtClean="0"/>
-              <a:t>4/2/2025</a:t>
+              <a:t>4/30/2025</a:t>
             </a:fld>
             <a:endParaRPr lang="en-US"/>
           </a:p>
@@ -1410,7 +1414,7 @@
           <a:p>
             <a:fld id="{877FD08C-8E7C-43AB-85E3-AC16F23677BF}" type="datetimeFigureOut">
               <a:rPr lang="en-US" smtClean="0"/>
-              <a:t>4/2/2025</a:t>
+              <a:t>4/30/2025</a:t>
             </a:fld>
             <a:endParaRPr lang="en-US"/>
           </a:p>
@@ -1822,7 +1826,7 @@
           <a:p>
             <a:fld id="{877FD08C-8E7C-43AB-85E3-AC16F23677BF}" type="datetimeFigureOut">
               <a:rPr lang="en-US" smtClean="0"/>
-              <a:t>4/2/2025</a:t>
+              <a:t>4/30/2025</a:t>
             </a:fld>
             <a:endParaRPr lang="en-US"/>
           </a:p>
@@ -1963,7 +1967,7 @@
           <a:p>
             <a:fld id="{877FD08C-8E7C-43AB-85E3-AC16F23677BF}" type="datetimeFigureOut">
               <a:rPr lang="en-US" smtClean="0"/>
-              <a:t>4/2/2025</a:t>
+              <a:t>4/30/2025</a:t>
             </a:fld>
             <a:endParaRPr lang="en-US"/>
           </a:p>
@@ -2076,7 +2080,7 @@
           <a:p>
             <a:fld id="{877FD08C-8E7C-43AB-85E3-AC16F23677BF}" type="datetimeFigureOut">
               <a:rPr lang="en-US" smtClean="0"/>
-              <a:t>4/2/2025</a:t>
+              <a:t>4/30/2025</a:t>
             </a:fld>
             <a:endParaRPr lang="en-US"/>
           </a:p>
@@ -2387,7 +2391,7 @@
           <a:p>
             <a:fld id="{877FD08C-8E7C-43AB-85E3-AC16F23677BF}" type="datetimeFigureOut">
               <a:rPr lang="en-US" smtClean="0"/>
-              <a:t>4/2/2025</a:t>
+              <a:t>4/30/2025</a:t>
             </a:fld>
             <a:endParaRPr lang="en-US"/>
           </a:p>
@@ -2675,7 +2679,7 @@
           <a:p>
             <a:fld id="{877FD08C-8E7C-43AB-85E3-AC16F23677BF}" type="datetimeFigureOut">
               <a:rPr lang="en-US" smtClean="0"/>
-              <a:t>4/2/2025</a:t>
+              <a:t>4/30/2025</a:t>
             </a:fld>
             <a:endParaRPr lang="en-US"/>
           </a:p>
@@ -2916,7 +2920,7 @@
           <a:p>
             <a:fld id="{877FD08C-8E7C-43AB-85E3-AC16F23677BF}" type="datetimeFigureOut">
               <a:rPr lang="en-US" smtClean="0"/>
-              <a:t>4/2/2025</a:t>
+              <a:t>4/30/2025</a:t>
             </a:fld>
             <a:endParaRPr lang="en-US"/>
           </a:p>
@@ -3401,6 +3405,726 @@
     <p:extLst>
       <p:ext uri="{BB962C8B-B14F-4D97-AF65-F5344CB8AC3E}">
         <p14:creationId xmlns:p14="http://schemas.microsoft.com/office/powerpoint/2010/main" val="1342260896"/>
+      </p:ext>
+    </p:extLst>
+  </p:cSld>
+  <p:clrMapOvr>
+    <a:masterClrMapping/>
+  </p:clrMapOvr>
+</p:sld>
+</file>
+
+<file path=ppt/slides/slide10.xml><?xml version="1.0" encoding="utf-8"?>
+<p:sld xmlns:a="http://schemas.openxmlformats.org/drawingml/2006/main" xmlns:r="http://schemas.openxmlformats.org/officeDocument/2006/relationships" xmlns:p="http://schemas.openxmlformats.org/presentationml/2006/main">
+  <p:cSld>
+    <p:spTree>
+      <p:nvGrpSpPr>
+        <p:cNvPr id="1" name="">
+          <a:extLst>
+            <a:ext uri="{FF2B5EF4-FFF2-40B4-BE49-F238E27FC236}">
+              <a16:creationId xmlns:a16="http://schemas.microsoft.com/office/drawing/2014/main" id="{589C51B0-6BDB-DE4F-3940-94DC25CB3FED}"/>
+            </a:ext>
+          </a:extLst>
+        </p:cNvPr>
+        <p:cNvGrpSpPr/>
+        <p:nvPr/>
+      </p:nvGrpSpPr>
+      <p:grpSpPr>
+        <a:xfrm>
+          <a:off x="0" y="0"/>
+          <a:ext cx="0" cy="0"/>
+          <a:chOff x="0" y="0"/>
+          <a:chExt cx="0" cy="0"/>
+        </a:xfrm>
+      </p:grpSpPr>
+      <p:sp>
+        <p:nvSpPr>
+          <p:cNvPr id="4" name="Title 1">
+            <a:extLst>
+              <a:ext uri="{FF2B5EF4-FFF2-40B4-BE49-F238E27FC236}">
+                <a16:creationId xmlns:a16="http://schemas.microsoft.com/office/drawing/2014/main" id="{DA36082F-2F0C-A54F-8587-F1C096017F69}"/>
+              </a:ext>
+            </a:extLst>
+          </p:cNvPr>
+          <p:cNvSpPr>
+            <a:spLocks noGrp="1"/>
+          </p:cNvSpPr>
+          <p:nvPr>
+            <p:ph type="title"/>
+          </p:nvPr>
+        </p:nvSpPr>
+        <p:spPr>
+          <a:xfrm>
+            <a:off x="0" y="1"/>
+            <a:ext cx="2479040" cy="568960"/>
+          </a:xfrm>
+        </p:spPr>
+        <p:txBody>
+          <a:bodyPr>
+            <a:normAutofit fontScale="90000"/>
+          </a:bodyPr>
+          <a:lstStyle/>
+          <a:p>
+            <a:r>
+              <a:rPr lang="en-US" sz="1800" dirty="0"/>
+              <a:t>Episode </a:t>
+            </a:r>
+            <a:br>
+              <a:rPr lang="en-US" sz="1800" dirty="0"/>
+            </a:br>
+            <a:r>
+              <a:rPr lang="en-US" sz="1800" dirty="0"/>
+              <a:t>lengths</a:t>
+            </a:r>
+          </a:p>
+        </p:txBody>
+      </p:sp>
+      <p:pic>
+        <p:nvPicPr>
+          <p:cNvPr id="5" name="Picture 4">
+            <a:extLst>
+              <a:ext uri="{FF2B5EF4-FFF2-40B4-BE49-F238E27FC236}">
+                <a16:creationId xmlns:a16="http://schemas.microsoft.com/office/drawing/2014/main" id="{0138078E-7ADB-7F57-0E5C-B6619623FADE}"/>
+              </a:ext>
+            </a:extLst>
+          </p:cNvPr>
+          <p:cNvPicPr>
+            <a:picLocks noChangeAspect="1"/>
+          </p:cNvPicPr>
+          <p:nvPr/>
+        </p:nvPicPr>
+        <p:blipFill>
+          <a:blip r:embed="rId2"/>
+          <a:stretch>
+            <a:fillRect/>
+          </a:stretch>
+        </p:blipFill>
+        <p:spPr>
+          <a:xfrm>
+            <a:off x="807720" y="5212080"/>
+            <a:ext cx="3861796" cy="1645920"/>
+          </a:xfrm>
+          <a:prstGeom prst="rect">
+            <a:avLst/>
+          </a:prstGeom>
+        </p:spPr>
+      </p:pic>
+      <p:pic>
+        <p:nvPicPr>
+          <p:cNvPr id="2" name="Picture 1">
+            <a:extLst>
+              <a:ext uri="{FF2B5EF4-FFF2-40B4-BE49-F238E27FC236}">
+                <a16:creationId xmlns:a16="http://schemas.microsoft.com/office/drawing/2014/main" id="{D7157F30-10CE-66EF-F527-8ED292D346C6}"/>
+              </a:ext>
+            </a:extLst>
+          </p:cNvPr>
+          <p:cNvPicPr>
+            <a:picLocks noChangeAspect="1"/>
+          </p:cNvPicPr>
+          <p:nvPr/>
+        </p:nvPicPr>
+        <p:blipFill>
+          <a:blip r:embed="rId3"/>
+          <a:stretch>
+            <a:fillRect/>
+          </a:stretch>
+        </p:blipFill>
+        <p:spPr>
+          <a:xfrm>
+            <a:off x="807720" y="3474893"/>
+            <a:ext cx="3861795" cy="1645920"/>
+          </a:xfrm>
+          <a:prstGeom prst="rect">
+            <a:avLst/>
+          </a:prstGeom>
+        </p:spPr>
+      </p:pic>
+      <p:pic>
+        <p:nvPicPr>
+          <p:cNvPr id="3" name="Picture 2">
+            <a:extLst>
+              <a:ext uri="{FF2B5EF4-FFF2-40B4-BE49-F238E27FC236}">
+                <a16:creationId xmlns:a16="http://schemas.microsoft.com/office/drawing/2014/main" id="{943035E6-95E9-4AE1-6EDA-ADDA1D8A0A26}"/>
+              </a:ext>
+            </a:extLst>
+          </p:cNvPr>
+          <p:cNvPicPr>
+            <a:picLocks noChangeAspect="1"/>
+          </p:cNvPicPr>
+          <p:nvPr/>
+        </p:nvPicPr>
+        <p:blipFill>
+          <a:blip r:embed="rId4"/>
+          <a:stretch>
+            <a:fillRect/>
+          </a:stretch>
+        </p:blipFill>
+        <p:spPr>
+          <a:xfrm>
+            <a:off x="807720" y="1737705"/>
+            <a:ext cx="3861796" cy="1645920"/>
+          </a:xfrm>
+          <a:prstGeom prst="rect">
+            <a:avLst/>
+          </a:prstGeom>
+        </p:spPr>
+      </p:pic>
+      <p:pic>
+        <p:nvPicPr>
+          <p:cNvPr id="6" name="Picture 5">
+            <a:extLst>
+              <a:ext uri="{FF2B5EF4-FFF2-40B4-BE49-F238E27FC236}">
+                <a16:creationId xmlns:a16="http://schemas.microsoft.com/office/drawing/2014/main" id="{2701F70F-EF8F-F71F-E455-0D5D90B59823}"/>
+              </a:ext>
+            </a:extLst>
+          </p:cNvPr>
+          <p:cNvPicPr>
+            <a:picLocks noChangeAspect="1"/>
+          </p:cNvPicPr>
+          <p:nvPr/>
+        </p:nvPicPr>
+        <p:blipFill>
+          <a:blip r:embed="rId5"/>
+          <a:stretch>
+            <a:fillRect/>
+          </a:stretch>
+        </p:blipFill>
+        <p:spPr>
+          <a:xfrm>
+            <a:off x="807720" y="517"/>
+            <a:ext cx="3861795" cy="1645920"/>
+          </a:xfrm>
+          <a:prstGeom prst="rect">
+            <a:avLst/>
+          </a:prstGeom>
+        </p:spPr>
+      </p:pic>
+      <p:pic>
+        <p:nvPicPr>
+          <p:cNvPr id="9" name="Picture 8">
+            <a:extLst>
+              <a:ext uri="{FF2B5EF4-FFF2-40B4-BE49-F238E27FC236}">
+                <a16:creationId xmlns:a16="http://schemas.microsoft.com/office/drawing/2014/main" id="{89DDFFAE-DF71-9B73-B638-DEE7BD53FD4E}"/>
+              </a:ext>
+            </a:extLst>
+          </p:cNvPr>
+          <p:cNvPicPr>
+            <a:picLocks noChangeAspect="1"/>
+          </p:cNvPicPr>
+          <p:nvPr/>
+        </p:nvPicPr>
+        <p:blipFill>
+          <a:blip r:embed="rId6"/>
+          <a:stretch>
+            <a:fillRect/>
+          </a:stretch>
+        </p:blipFill>
+        <p:spPr>
+          <a:xfrm>
+            <a:off x="5506720" y="0"/>
+            <a:ext cx="3861797" cy="1645920"/>
+          </a:xfrm>
+          <a:prstGeom prst="rect">
+            <a:avLst/>
+          </a:prstGeom>
+        </p:spPr>
+      </p:pic>
+      <p:pic>
+        <p:nvPicPr>
+          <p:cNvPr id="11" name="Picture 10">
+            <a:extLst>
+              <a:ext uri="{FF2B5EF4-FFF2-40B4-BE49-F238E27FC236}">
+                <a16:creationId xmlns:a16="http://schemas.microsoft.com/office/drawing/2014/main" id="{1E51D2F8-C79E-508F-DD65-06A837ECAAD0}"/>
+              </a:ext>
+            </a:extLst>
+          </p:cNvPr>
+          <p:cNvPicPr>
+            <a:picLocks noChangeAspect="1"/>
+          </p:cNvPicPr>
+          <p:nvPr/>
+        </p:nvPicPr>
+        <p:blipFill>
+          <a:blip r:embed="rId7"/>
+          <a:stretch>
+            <a:fillRect/>
+          </a:stretch>
+        </p:blipFill>
+        <p:spPr>
+          <a:xfrm>
+            <a:off x="5506720" y="1645920"/>
+            <a:ext cx="3861795" cy="1645920"/>
+          </a:xfrm>
+          <a:prstGeom prst="rect">
+            <a:avLst/>
+          </a:prstGeom>
+        </p:spPr>
+      </p:pic>
+      <p:pic>
+        <p:nvPicPr>
+          <p:cNvPr id="13" name="Picture 12">
+            <a:extLst>
+              <a:ext uri="{FF2B5EF4-FFF2-40B4-BE49-F238E27FC236}">
+                <a16:creationId xmlns:a16="http://schemas.microsoft.com/office/drawing/2014/main" id="{44A343A7-4D96-1A7D-5A4D-FE6763A2B30C}"/>
+              </a:ext>
+            </a:extLst>
+          </p:cNvPr>
+          <p:cNvPicPr>
+            <a:picLocks noChangeAspect="1"/>
+          </p:cNvPicPr>
+          <p:nvPr/>
+        </p:nvPicPr>
+        <p:blipFill>
+          <a:blip r:embed="rId8"/>
+          <a:stretch>
+            <a:fillRect/>
+          </a:stretch>
+        </p:blipFill>
+        <p:spPr>
+          <a:xfrm>
+            <a:off x="5506720" y="3383625"/>
+            <a:ext cx="3861797" cy="1645920"/>
+          </a:xfrm>
+          <a:prstGeom prst="rect">
+            <a:avLst/>
+          </a:prstGeom>
+        </p:spPr>
+      </p:pic>
+      <p:pic>
+        <p:nvPicPr>
+          <p:cNvPr id="15" name="Picture 14">
+            <a:extLst>
+              <a:ext uri="{FF2B5EF4-FFF2-40B4-BE49-F238E27FC236}">
+                <a16:creationId xmlns:a16="http://schemas.microsoft.com/office/drawing/2014/main" id="{6068A86D-913F-472B-8B3A-6A59E89B687D}"/>
+              </a:ext>
+            </a:extLst>
+          </p:cNvPr>
+          <p:cNvPicPr>
+            <a:picLocks noChangeAspect="1"/>
+          </p:cNvPicPr>
+          <p:nvPr/>
+        </p:nvPicPr>
+        <p:blipFill>
+          <a:blip r:embed="rId9"/>
+          <a:stretch>
+            <a:fillRect/>
+          </a:stretch>
+        </p:blipFill>
+        <p:spPr>
+          <a:xfrm>
+            <a:off x="5506719" y="5212080"/>
+            <a:ext cx="3861795" cy="1645920"/>
+          </a:xfrm>
+          <a:prstGeom prst="rect">
+            <a:avLst/>
+          </a:prstGeom>
+        </p:spPr>
+      </p:pic>
+      <p:sp>
+        <p:nvSpPr>
+          <p:cNvPr id="16" name="Title 1">
+            <a:extLst>
+              <a:ext uri="{FF2B5EF4-FFF2-40B4-BE49-F238E27FC236}">
+                <a16:creationId xmlns:a16="http://schemas.microsoft.com/office/drawing/2014/main" id="{0A13D80C-A853-D29D-4128-7C9BECA26A36}"/>
+              </a:ext>
+            </a:extLst>
+          </p:cNvPr>
+          <p:cNvSpPr txBox="1">
+            <a:spLocks/>
+          </p:cNvSpPr>
+          <p:nvPr/>
+        </p:nvSpPr>
+        <p:spPr>
+          <a:xfrm>
+            <a:off x="4775200" y="1"/>
+            <a:ext cx="2479040" cy="568960"/>
+          </a:xfrm>
+          <a:prstGeom prst="rect">
+            <a:avLst/>
+          </a:prstGeom>
+        </p:spPr>
+        <p:txBody>
+          <a:bodyPr vert="horz" lIns="91440" tIns="45720" rIns="91440" bIns="45720" rtlCol="0" anchor="ctr">
+            <a:normAutofit/>
+          </a:bodyPr>
+          <a:lstStyle>
+            <a:lvl1pPr algn="l" defTabSz="914400" rtl="0" eaLnBrk="1" latinLnBrk="0" hangingPunct="1">
+              <a:lnSpc>
+                <a:spcPct val="90000"/>
+              </a:lnSpc>
+              <a:spcBef>
+                <a:spcPct val="0"/>
+              </a:spcBef>
+              <a:buNone/>
+              <a:defRPr sz="4400" kern="1200">
+                <a:solidFill>
+                  <a:schemeClr val="tx1"/>
+                </a:solidFill>
+                <a:latin typeface="+mj-lt"/>
+                <a:ea typeface="+mj-ea"/>
+                <a:cs typeface="+mj-cs"/>
+              </a:defRPr>
+            </a:lvl1pPr>
+          </a:lstStyle>
+          <a:p>
+            <a:r>
+              <a:rPr lang="en-US" sz="1800" dirty="0"/>
+              <a:t>Errors</a:t>
+            </a:r>
+          </a:p>
+        </p:txBody>
+      </p:sp>
+      <p:sp>
+        <p:nvSpPr>
+          <p:cNvPr id="17" name="Title 1">
+            <a:extLst>
+              <a:ext uri="{FF2B5EF4-FFF2-40B4-BE49-F238E27FC236}">
+                <a16:creationId xmlns:a16="http://schemas.microsoft.com/office/drawing/2014/main" id="{C27CDE14-61B1-AEC5-9A5E-C995A4A2928D}"/>
+              </a:ext>
+            </a:extLst>
+          </p:cNvPr>
+          <p:cNvSpPr txBox="1">
+            <a:spLocks/>
+          </p:cNvSpPr>
+          <p:nvPr/>
+        </p:nvSpPr>
+        <p:spPr>
+          <a:xfrm>
+            <a:off x="9829800" y="2258060"/>
+            <a:ext cx="2362200" cy="2341879"/>
+          </a:xfrm>
+          <a:prstGeom prst="rect">
+            <a:avLst/>
+          </a:prstGeom>
+        </p:spPr>
+        <p:txBody>
+          <a:bodyPr vert="horz" lIns="91440" tIns="45720" rIns="91440" bIns="45720" rtlCol="0" anchor="ctr">
+            <a:normAutofit/>
+          </a:bodyPr>
+          <a:lstStyle>
+            <a:lvl1pPr algn="l" defTabSz="914400" rtl="0" eaLnBrk="1" latinLnBrk="0" hangingPunct="1">
+              <a:lnSpc>
+                <a:spcPct val="90000"/>
+              </a:lnSpc>
+              <a:spcBef>
+                <a:spcPct val="0"/>
+              </a:spcBef>
+              <a:buNone/>
+              <a:defRPr sz="4400" kern="1200">
+                <a:solidFill>
+                  <a:schemeClr val="tx1"/>
+                </a:solidFill>
+                <a:latin typeface="+mj-lt"/>
+                <a:ea typeface="+mj-ea"/>
+                <a:cs typeface="+mj-cs"/>
+              </a:defRPr>
+            </a:lvl1pPr>
+          </a:lstStyle>
+          <a:p>
+            <a:r>
+              <a:rPr lang="en-US" sz="1800" dirty="0"/>
+              <a:t>RL models can’t deal with noise</a:t>
+            </a:r>
+          </a:p>
+          <a:p>
+            <a:endParaRPr lang="en-US" sz="1800" dirty="0"/>
+          </a:p>
+          <a:p>
+            <a:r>
+              <a:rPr lang="en-US" sz="1800" dirty="0"/>
+              <a:t>MPC can deal with noise at specific horizons</a:t>
+            </a:r>
+          </a:p>
+          <a:p>
+            <a:endParaRPr lang="en-US" sz="1800" dirty="0"/>
+          </a:p>
+          <a:p>
+            <a:r>
+              <a:rPr lang="en-US" sz="1800" dirty="0"/>
+              <a:t>Why is horizon 40 so good?</a:t>
+            </a:r>
+          </a:p>
+        </p:txBody>
+      </p:sp>
+    </p:spTree>
+    <p:extLst>
+      <p:ext uri="{BB962C8B-B14F-4D97-AF65-F5344CB8AC3E}">
+        <p14:creationId xmlns:p14="http://schemas.microsoft.com/office/powerpoint/2010/main" val="821258998"/>
+      </p:ext>
+    </p:extLst>
+  </p:cSld>
+  <p:clrMapOvr>
+    <a:masterClrMapping/>
+  </p:clrMapOvr>
+</p:sld>
+</file>
+
+<file path=ppt/slides/slide11.xml><?xml version="1.0" encoding="utf-8"?>
+<p:sld xmlns:a="http://schemas.openxmlformats.org/drawingml/2006/main" xmlns:r="http://schemas.openxmlformats.org/officeDocument/2006/relationships" xmlns:p="http://schemas.openxmlformats.org/presentationml/2006/main">
+  <p:cSld>
+    <p:spTree>
+      <p:nvGrpSpPr>
+        <p:cNvPr id="1" name="">
+          <a:extLst>
+            <a:ext uri="{FF2B5EF4-FFF2-40B4-BE49-F238E27FC236}">
+              <a16:creationId xmlns:a16="http://schemas.microsoft.com/office/drawing/2014/main" id="{E4FD27E1-F45B-C5BF-58DA-75608C275484}"/>
+            </a:ext>
+          </a:extLst>
+        </p:cNvPr>
+        <p:cNvGrpSpPr/>
+        <p:nvPr/>
+      </p:nvGrpSpPr>
+      <p:grpSpPr>
+        <a:xfrm>
+          <a:off x="0" y="0"/>
+          <a:ext cx="0" cy="0"/>
+          <a:chOff x="0" y="0"/>
+          <a:chExt cx="0" cy="0"/>
+        </a:xfrm>
+      </p:grpSpPr>
+      <p:sp>
+        <p:nvSpPr>
+          <p:cNvPr id="4" name="Title 1">
+            <a:extLst>
+              <a:ext uri="{FF2B5EF4-FFF2-40B4-BE49-F238E27FC236}">
+                <a16:creationId xmlns:a16="http://schemas.microsoft.com/office/drawing/2014/main" id="{2762266A-D276-3C11-17C6-0674AB05AFC3}"/>
+              </a:ext>
+            </a:extLst>
+          </p:cNvPr>
+          <p:cNvSpPr>
+            <a:spLocks noGrp="1"/>
+          </p:cNvSpPr>
+          <p:nvPr>
+            <p:ph type="title"/>
+          </p:nvPr>
+        </p:nvSpPr>
+        <p:spPr>
+          <a:xfrm>
+            <a:off x="0" y="0"/>
+            <a:ext cx="10515600" cy="1325563"/>
+          </a:xfrm>
+        </p:spPr>
+        <p:txBody>
+          <a:bodyPr>
+            <a:normAutofit/>
+          </a:bodyPr>
+          <a:lstStyle/>
+          <a:p>
+            <a:r>
+              <a:rPr lang="en-US" sz="2800" dirty="0"/>
+              <a:t>Integrated errors metric</a:t>
+            </a:r>
+            <a:br>
+              <a:rPr lang="en-US" sz="2800" dirty="0"/>
+            </a:br>
+            <a:r>
+              <a:rPr lang="en-US" sz="2800" dirty="0"/>
+              <a:t>(no noise)</a:t>
+            </a:r>
+          </a:p>
+        </p:txBody>
+      </p:sp>
+      <p:pic>
+        <p:nvPicPr>
+          <p:cNvPr id="3" name="Picture 2">
+            <a:extLst>
+              <a:ext uri="{FF2B5EF4-FFF2-40B4-BE49-F238E27FC236}">
+                <a16:creationId xmlns:a16="http://schemas.microsoft.com/office/drawing/2014/main" id="{75BA8F4E-4890-5D10-24DE-8F870D041A52}"/>
+              </a:ext>
+            </a:extLst>
+          </p:cNvPr>
+          <p:cNvPicPr>
+            <a:picLocks noChangeAspect="1"/>
+          </p:cNvPicPr>
+          <p:nvPr/>
+        </p:nvPicPr>
+        <p:blipFill>
+          <a:blip r:embed="rId2"/>
+          <a:stretch>
+            <a:fillRect/>
+          </a:stretch>
+        </p:blipFill>
+        <p:spPr>
+          <a:xfrm>
+            <a:off x="4363720" y="3520440"/>
+            <a:ext cx="7830864" cy="3337560"/>
+          </a:xfrm>
+          <a:prstGeom prst="rect">
+            <a:avLst/>
+          </a:prstGeom>
+        </p:spPr>
+      </p:pic>
+      <p:pic>
+        <p:nvPicPr>
+          <p:cNvPr id="6" name="Picture 5">
+            <a:extLst>
+              <a:ext uri="{FF2B5EF4-FFF2-40B4-BE49-F238E27FC236}">
+                <a16:creationId xmlns:a16="http://schemas.microsoft.com/office/drawing/2014/main" id="{8615CCA8-CCFA-0CB2-FE8F-0E9A84A6718F}"/>
+              </a:ext>
+            </a:extLst>
+          </p:cNvPr>
+          <p:cNvPicPr>
+            <a:picLocks noChangeAspect="1"/>
+          </p:cNvPicPr>
+          <p:nvPr/>
+        </p:nvPicPr>
+        <p:blipFill>
+          <a:blip r:embed="rId3"/>
+          <a:stretch>
+            <a:fillRect/>
+          </a:stretch>
+        </p:blipFill>
+        <p:spPr>
+          <a:xfrm>
+            <a:off x="4363720" y="60960"/>
+            <a:ext cx="7828280" cy="3336459"/>
+          </a:xfrm>
+          <a:prstGeom prst="rect">
+            <a:avLst/>
+          </a:prstGeom>
+        </p:spPr>
+      </p:pic>
+    </p:spTree>
+    <p:extLst>
+      <p:ext uri="{BB962C8B-B14F-4D97-AF65-F5344CB8AC3E}">
+        <p14:creationId xmlns:p14="http://schemas.microsoft.com/office/powerpoint/2010/main" val="2208520805"/>
+      </p:ext>
+    </p:extLst>
+  </p:cSld>
+  <p:clrMapOvr>
+    <a:masterClrMapping/>
+  </p:clrMapOvr>
+</p:sld>
+</file>
+
+<file path=ppt/slides/slide12.xml><?xml version="1.0" encoding="utf-8"?>
+<p:sld xmlns:a="http://schemas.openxmlformats.org/drawingml/2006/main" xmlns:r="http://schemas.openxmlformats.org/officeDocument/2006/relationships" xmlns:p="http://schemas.openxmlformats.org/presentationml/2006/main">
+  <p:cSld>
+    <p:spTree>
+      <p:nvGrpSpPr>
+        <p:cNvPr id="1" name="">
+          <a:extLst>
+            <a:ext uri="{FF2B5EF4-FFF2-40B4-BE49-F238E27FC236}">
+              <a16:creationId xmlns:a16="http://schemas.microsoft.com/office/drawing/2014/main" id="{F3573402-7B72-8442-7B11-6DA88DB9B97E}"/>
+            </a:ext>
+          </a:extLst>
+        </p:cNvPr>
+        <p:cNvGrpSpPr/>
+        <p:nvPr/>
+      </p:nvGrpSpPr>
+      <p:grpSpPr>
+        <a:xfrm>
+          <a:off x="0" y="0"/>
+          <a:ext cx="0" cy="0"/>
+          <a:chOff x="0" y="0"/>
+          <a:chExt cx="0" cy="0"/>
+        </a:xfrm>
+      </p:grpSpPr>
+      <p:sp>
+        <p:nvSpPr>
+          <p:cNvPr id="4" name="Title 1">
+            <a:extLst>
+              <a:ext uri="{FF2B5EF4-FFF2-40B4-BE49-F238E27FC236}">
+                <a16:creationId xmlns:a16="http://schemas.microsoft.com/office/drawing/2014/main" id="{B986997A-7419-7177-6D89-FD07DEED3F9D}"/>
+              </a:ext>
+            </a:extLst>
+          </p:cNvPr>
+          <p:cNvSpPr>
+            <a:spLocks noGrp="1"/>
+          </p:cNvSpPr>
+          <p:nvPr>
+            <p:ph type="title"/>
+          </p:nvPr>
+        </p:nvSpPr>
+        <p:spPr>
+          <a:xfrm>
+            <a:off x="0" y="0"/>
+            <a:ext cx="10515600" cy="1325563"/>
+          </a:xfrm>
+        </p:spPr>
+        <p:txBody>
+          <a:bodyPr>
+            <a:normAutofit/>
+          </a:bodyPr>
+          <a:lstStyle/>
+          <a:p>
+            <a:r>
+              <a:rPr lang="en-US" sz="2800" dirty="0"/>
+              <a:t>Integrated errors metric</a:t>
+            </a:r>
+            <a:br>
+              <a:rPr lang="en-US" sz="2800" dirty="0"/>
+            </a:br>
+            <a:r>
+              <a:rPr lang="en-US" sz="2800" dirty="0"/>
+              <a:t>(max noise)</a:t>
+            </a:r>
+          </a:p>
+        </p:txBody>
+      </p:sp>
+      <p:pic>
+        <p:nvPicPr>
+          <p:cNvPr id="2" name="Picture 1">
+            <a:extLst>
+              <a:ext uri="{FF2B5EF4-FFF2-40B4-BE49-F238E27FC236}">
+                <a16:creationId xmlns:a16="http://schemas.microsoft.com/office/drawing/2014/main" id="{F65170A1-D50C-F607-382C-7B898D6ECA31}"/>
+              </a:ext>
+            </a:extLst>
+          </p:cNvPr>
+          <p:cNvPicPr>
+            <a:picLocks noChangeAspect="1"/>
+          </p:cNvPicPr>
+          <p:nvPr/>
+        </p:nvPicPr>
+        <p:blipFill>
+          <a:blip r:embed="rId2"/>
+          <a:stretch>
+            <a:fillRect/>
+          </a:stretch>
+        </p:blipFill>
+        <p:spPr>
+          <a:xfrm>
+            <a:off x="4361136" y="91440"/>
+            <a:ext cx="7830864" cy="3337560"/>
+          </a:xfrm>
+          <a:prstGeom prst="rect">
+            <a:avLst/>
+          </a:prstGeom>
+        </p:spPr>
+      </p:pic>
+      <p:pic>
+        <p:nvPicPr>
+          <p:cNvPr id="7" name="Picture 6">
+            <a:extLst>
+              <a:ext uri="{FF2B5EF4-FFF2-40B4-BE49-F238E27FC236}">
+                <a16:creationId xmlns:a16="http://schemas.microsoft.com/office/drawing/2014/main" id="{E908DC13-F958-63F7-DAD1-DA72EF00A831}"/>
+              </a:ext>
+            </a:extLst>
+          </p:cNvPr>
+          <p:cNvPicPr>
+            <a:picLocks noChangeAspect="1"/>
+          </p:cNvPicPr>
+          <p:nvPr/>
+        </p:nvPicPr>
+        <p:blipFill>
+          <a:blip r:embed="rId3"/>
+          <a:stretch>
+            <a:fillRect/>
+          </a:stretch>
+        </p:blipFill>
+        <p:spPr>
+          <a:xfrm>
+            <a:off x="4361136" y="3520440"/>
+            <a:ext cx="7830863" cy="3337560"/>
+          </a:xfrm>
+          <a:prstGeom prst="rect">
+            <a:avLst/>
+          </a:prstGeom>
+        </p:spPr>
+      </p:pic>
+    </p:spTree>
+    <p:extLst>
+      <p:ext uri="{BB962C8B-B14F-4D97-AF65-F5344CB8AC3E}">
+        <p14:creationId xmlns:p14="http://schemas.microsoft.com/office/powerpoint/2010/main" val="1004361906"/>
       </p:ext>
     </p:extLst>
   </p:cSld>
@@ -4783,118 +5507,6 @@
         <p:cNvPr id="1" name="">
           <a:extLst>
             <a:ext uri="{FF2B5EF4-FFF2-40B4-BE49-F238E27FC236}">
-              <a16:creationId xmlns:a16="http://schemas.microsoft.com/office/drawing/2014/main" id="{408E7A22-FEEF-C36E-61D7-0BD615B53D37}"/>
-            </a:ext>
-          </a:extLst>
-        </p:cNvPr>
-        <p:cNvGrpSpPr/>
-        <p:nvPr/>
-      </p:nvGrpSpPr>
-      <p:grpSpPr>
-        <a:xfrm>
-          <a:off x="0" y="0"/>
-          <a:ext cx="0" cy="0"/>
-          <a:chOff x="0" y="0"/>
-          <a:chExt cx="0" cy="0"/>
-        </a:xfrm>
-      </p:grpSpPr>
-      <p:sp>
-        <p:nvSpPr>
-          <p:cNvPr id="4" name="Title 1">
-            <a:extLst>
-              <a:ext uri="{FF2B5EF4-FFF2-40B4-BE49-F238E27FC236}">
-                <a16:creationId xmlns:a16="http://schemas.microsoft.com/office/drawing/2014/main" id="{431EFEFC-16CC-0999-2621-EE0FB63C78F3}"/>
-              </a:ext>
-            </a:extLst>
-          </p:cNvPr>
-          <p:cNvSpPr>
-            <a:spLocks noGrp="1"/>
-          </p:cNvSpPr>
-          <p:nvPr>
-            <p:ph type="title"/>
-          </p:nvPr>
-        </p:nvSpPr>
-        <p:spPr>
-          <a:xfrm>
-            <a:off x="0" y="0"/>
-            <a:ext cx="10515600" cy="1325563"/>
-          </a:xfrm>
-        </p:spPr>
-        <p:txBody>
-          <a:bodyPr>
-            <a:normAutofit/>
-          </a:bodyPr>
-          <a:lstStyle/>
-          <a:p>
-            <a:r>
-              <a:rPr lang="en-US" sz="3200" dirty="0"/>
-              <a:t>Results – </a:t>
-            </a:r>
-            <a:r>
-              <a:rPr lang="en-US" sz="3200"/>
-              <a:t>low noise (non-linear dynamics MPC)</a:t>
-            </a:r>
-            <a:endParaRPr lang="en-US" sz="3200" dirty="0"/>
-          </a:p>
-        </p:txBody>
-      </p:sp>
-      <p:pic>
-        <p:nvPicPr>
-          <p:cNvPr id="2" name="Picture 1" descr="A graph of different colored lines&#10;&#10;AI-generated content may be incorrect.">
-            <a:extLst>
-              <a:ext uri="{FF2B5EF4-FFF2-40B4-BE49-F238E27FC236}">
-                <a16:creationId xmlns:a16="http://schemas.microsoft.com/office/drawing/2014/main" id="{E1D2BDE0-A476-DB54-FB9F-55346C99BD25}"/>
-              </a:ext>
-            </a:extLst>
-          </p:cNvPr>
-          <p:cNvPicPr>
-            <a:picLocks noChangeAspect="1"/>
-          </p:cNvPicPr>
-          <p:nvPr/>
-        </p:nvPicPr>
-        <p:blipFill>
-          <a:blip r:embed="rId2">
-            <a:extLst>
-              <a:ext uri="{28A0092B-C50C-407E-A947-70E740481C1C}">
-                <a14:useLocalDpi xmlns:a14="http://schemas.microsoft.com/office/drawing/2010/main" val="0"/>
-              </a:ext>
-            </a:extLst>
-          </a:blip>
-          <a:stretch>
-            <a:fillRect/>
-          </a:stretch>
-        </p:blipFill>
-        <p:spPr>
-          <a:xfrm>
-            <a:off x="789421" y="1399021"/>
-            <a:ext cx="10613158" cy="5458979"/>
-          </a:xfrm>
-          <a:prstGeom prst="rect">
-            <a:avLst/>
-          </a:prstGeom>
-        </p:spPr>
-      </p:pic>
-    </p:spTree>
-    <p:extLst>
-      <p:ext uri="{BB962C8B-B14F-4D97-AF65-F5344CB8AC3E}">
-        <p14:creationId xmlns:p14="http://schemas.microsoft.com/office/powerpoint/2010/main" val="392941608"/>
-      </p:ext>
-    </p:extLst>
-  </p:cSld>
-  <p:clrMapOvr>
-    <a:masterClrMapping/>
-  </p:clrMapOvr>
-</p:sld>
-</file>
-
-<file path=ppt/slides/slide7.xml><?xml version="1.0" encoding="utf-8"?>
-<p:sld xmlns:a="http://schemas.openxmlformats.org/drawingml/2006/main" xmlns:r="http://schemas.openxmlformats.org/officeDocument/2006/relationships" xmlns:p="http://schemas.openxmlformats.org/presentationml/2006/main">
-  <p:cSld>
-    <p:spTree>
-      <p:nvGrpSpPr>
-        <p:cNvPr id="1" name="">
-          <a:extLst>
-            <a:ext uri="{FF2B5EF4-FFF2-40B4-BE49-F238E27FC236}">
               <a16:creationId xmlns:a16="http://schemas.microsoft.com/office/drawing/2014/main" id="{86656A7C-5A2F-9615-6A8D-581CC4E86EC9}"/>
             </a:ext>
           </a:extLst>
@@ -4940,17 +5552,17 @@
           <a:p>
             <a:r>
               <a:rPr lang="en-US" sz="3200" dirty="0"/>
-              <a:t>Results – high noise (non-linear dynamics MPC)</a:t>
+              <a:t>Results – no noise (non-linear dynamics MPC)</a:t>
             </a:r>
           </a:p>
         </p:txBody>
       </p:sp>
       <p:pic>
         <p:nvPicPr>
-          <p:cNvPr id="7" name="Picture 6" descr="A graph of different colored lines&#10;&#10;AI-generated content may be incorrect.">
-            <a:extLst>
-              <a:ext uri="{FF2B5EF4-FFF2-40B4-BE49-F238E27FC236}">
-                <a16:creationId xmlns:a16="http://schemas.microsoft.com/office/drawing/2014/main" id="{A47557B7-03E7-0F3A-C33F-3F1DC84E0A13}"/>
+          <p:cNvPr id="3" name="Picture 2">
+            <a:extLst>
+              <a:ext uri="{FF2B5EF4-FFF2-40B4-BE49-F238E27FC236}">
+                <a16:creationId xmlns:a16="http://schemas.microsoft.com/office/drawing/2014/main" id="{E4546E93-FFFF-144C-24B6-AB73398C6E6A}"/>
               </a:ext>
             </a:extLst>
           </p:cNvPr>
@@ -4960,21 +5572,15 @@
           <p:nvPr/>
         </p:nvPicPr>
         <p:blipFill>
-          <a:blip r:embed="rId2">
-            <a:extLst>
-              <a:ext uri="{28A0092B-C50C-407E-A947-70E740481C1C}">
-                <a14:useLocalDpi xmlns:a14="http://schemas.microsoft.com/office/drawing/2010/main" val="0"/>
-              </a:ext>
-            </a:extLst>
-          </a:blip>
+          <a:blip r:embed="rId2"/>
           <a:stretch>
             <a:fillRect/>
           </a:stretch>
         </p:blipFill>
         <p:spPr>
           <a:xfrm>
-            <a:off x="789421" y="1399021"/>
-            <a:ext cx="10613158" cy="5458979"/>
+            <a:off x="0" y="1661698"/>
+            <a:ext cx="12192000" cy="5196302"/>
           </a:xfrm>
           <a:prstGeom prst="rect">
             <a:avLst/>
@@ -4994,7 +5600,7 @@
 </p:sld>
 </file>
 
-<file path=ppt/slides/slide8.xml><?xml version="1.0" encoding="utf-8"?>
+<file path=ppt/slides/slide7.xml><?xml version="1.0" encoding="utf-8"?>
 <p:sld xmlns:a="http://schemas.openxmlformats.org/drawingml/2006/main" xmlns:r="http://schemas.openxmlformats.org/officeDocument/2006/relationships" xmlns:p="http://schemas.openxmlformats.org/presentationml/2006/main">
   <p:cSld>
     <p:spTree>
@@ -5002,7 +5608,7 @@
         <p:cNvPr id="1" name="">
           <a:extLst>
             <a:ext uri="{FF2B5EF4-FFF2-40B4-BE49-F238E27FC236}">
-              <a16:creationId xmlns:a16="http://schemas.microsoft.com/office/drawing/2014/main" id="{4A158A3E-0FDA-06F7-C5EF-3A6F2FB4EFD3}"/>
+              <a16:creationId xmlns:a16="http://schemas.microsoft.com/office/drawing/2014/main" id="{0631E453-B4FD-B6F1-6204-BCED42A931B7}"/>
             </a:ext>
           </a:extLst>
         </p:cNvPr>
@@ -5022,7 +5628,7 @@
           <p:cNvPr id="4" name="Title 1">
             <a:extLst>
               <a:ext uri="{FF2B5EF4-FFF2-40B4-BE49-F238E27FC236}">
-                <a16:creationId xmlns:a16="http://schemas.microsoft.com/office/drawing/2014/main" id="{A2B29E96-00E7-9635-74C7-3BEB2E0FD98F}"/>
+                <a16:creationId xmlns:a16="http://schemas.microsoft.com/office/drawing/2014/main" id="{FA4BC56D-16F5-CAF8-CC20-13507F96B4B9}"/>
               </a:ext>
             </a:extLst>
           </p:cNvPr>
@@ -5035,7 +5641,7 @@
         </p:nvSpPr>
         <p:spPr>
           <a:xfrm>
-            <a:off x="708991" y="2590800"/>
+            <a:off x="0" y="0"/>
             <a:ext cx="10515600" cy="1325563"/>
           </a:xfrm>
         </p:spPr>
@@ -5046,16 +5652,248 @@
           <a:lstStyle/>
           <a:p>
             <a:r>
-              <a:rPr lang="en-US" sz="3200" b="1" u="sng" dirty="0"/>
-              <a:t>Error measure: integrated distance from vertical position</a:t>
-            </a:r>
-          </a:p>
-        </p:txBody>
-      </p:sp>
+              <a:rPr lang="en-US" sz="3200" dirty="0"/>
+              <a:t>Results – 0.2 noise (non-linear dynamics MPC)</a:t>
+            </a:r>
+          </a:p>
+        </p:txBody>
+      </p:sp>
+      <p:pic>
+        <p:nvPicPr>
+          <p:cNvPr id="5" name="Picture 4">
+            <a:extLst>
+              <a:ext uri="{FF2B5EF4-FFF2-40B4-BE49-F238E27FC236}">
+                <a16:creationId xmlns:a16="http://schemas.microsoft.com/office/drawing/2014/main" id="{D7A71C40-BB9A-0862-5086-58767E216675}"/>
+              </a:ext>
+            </a:extLst>
+          </p:cNvPr>
+          <p:cNvPicPr>
+            <a:picLocks noChangeAspect="1"/>
+          </p:cNvPicPr>
+          <p:nvPr/>
+        </p:nvPicPr>
+        <p:blipFill>
+          <a:blip r:embed="rId2"/>
+          <a:stretch>
+            <a:fillRect/>
+          </a:stretch>
+        </p:blipFill>
+        <p:spPr>
+          <a:xfrm>
+            <a:off x="0" y="1661698"/>
+            <a:ext cx="12192000" cy="5196302"/>
+          </a:xfrm>
+          <a:prstGeom prst="rect">
+            <a:avLst/>
+          </a:prstGeom>
+        </p:spPr>
+      </p:pic>
     </p:spTree>
     <p:extLst>
       <p:ext uri="{BB962C8B-B14F-4D97-AF65-F5344CB8AC3E}">
-        <p14:creationId xmlns:p14="http://schemas.microsoft.com/office/powerpoint/2010/main" val="697003045"/>
+        <p14:creationId xmlns:p14="http://schemas.microsoft.com/office/powerpoint/2010/main" val="69985812"/>
+      </p:ext>
+    </p:extLst>
+  </p:cSld>
+  <p:clrMapOvr>
+    <a:masterClrMapping/>
+  </p:clrMapOvr>
+</p:sld>
+</file>
+
+<file path=ppt/slides/slide8.xml><?xml version="1.0" encoding="utf-8"?>
+<p:sld xmlns:a="http://schemas.openxmlformats.org/drawingml/2006/main" xmlns:r="http://schemas.openxmlformats.org/officeDocument/2006/relationships" xmlns:p="http://schemas.openxmlformats.org/presentationml/2006/main">
+  <p:cSld>
+    <p:spTree>
+      <p:nvGrpSpPr>
+        <p:cNvPr id="1" name="">
+          <a:extLst>
+            <a:ext uri="{FF2B5EF4-FFF2-40B4-BE49-F238E27FC236}">
+              <a16:creationId xmlns:a16="http://schemas.microsoft.com/office/drawing/2014/main" id="{75987105-A460-9A6A-5708-11CA83C539D2}"/>
+            </a:ext>
+          </a:extLst>
+        </p:cNvPr>
+        <p:cNvGrpSpPr/>
+        <p:nvPr/>
+      </p:nvGrpSpPr>
+      <p:grpSpPr>
+        <a:xfrm>
+          <a:off x="0" y="0"/>
+          <a:ext cx="0" cy="0"/>
+          <a:chOff x="0" y="0"/>
+          <a:chExt cx="0" cy="0"/>
+        </a:xfrm>
+      </p:grpSpPr>
+      <p:sp>
+        <p:nvSpPr>
+          <p:cNvPr id="4" name="Title 1">
+            <a:extLst>
+              <a:ext uri="{FF2B5EF4-FFF2-40B4-BE49-F238E27FC236}">
+                <a16:creationId xmlns:a16="http://schemas.microsoft.com/office/drawing/2014/main" id="{47D3B38D-E559-B481-4A64-1ABC01B88CFF}"/>
+              </a:ext>
+            </a:extLst>
+          </p:cNvPr>
+          <p:cNvSpPr>
+            <a:spLocks noGrp="1"/>
+          </p:cNvSpPr>
+          <p:nvPr>
+            <p:ph type="title"/>
+          </p:nvPr>
+        </p:nvSpPr>
+        <p:spPr>
+          <a:xfrm>
+            <a:off x="0" y="0"/>
+            <a:ext cx="10515600" cy="1325563"/>
+          </a:xfrm>
+        </p:spPr>
+        <p:txBody>
+          <a:bodyPr>
+            <a:normAutofit/>
+          </a:bodyPr>
+          <a:lstStyle/>
+          <a:p>
+            <a:r>
+              <a:rPr lang="en-US" sz="3200" dirty="0"/>
+              <a:t>Results – 0.4 noise (non-linear dynamics MPC)</a:t>
+            </a:r>
+          </a:p>
+        </p:txBody>
+      </p:sp>
+      <p:pic>
+        <p:nvPicPr>
+          <p:cNvPr id="3" name="Picture 2">
+            <a:extLst>
+              <a:ext uri="{FF2B5EF4-FFF2-40B4-BE49-F238E27FC236}">
+                <a16:creationId xmlns:a16="http://schemas.microsoft.com/office/drawing/2014/main" id="{A2A9519C-2387-1E42-87B8-F9A3B8F29041}"/>
+              </a:ext>
+            </a:extLst>
+          </p:cNvPr>
+          <p:cNvPicPr>
+            <a:picLocks noChangeAspect="1"/>
+          </p:cNvPicPr>
+          <p:nvPr/>
+        </p:nvPicPr>
+        <p:blipFill>
+          <a:blip r:embed="rId2"/>
+          <a:stretch>
+            <a:fillRect/>
+          </a:stretch>
+        </p:blipFill>
+        <p:spPr>
+          <a:xfrm>
+            <a:off x="0" y="1661698"/>
+            <a:ext cx="12192000" cy="5196302"/>
+          </a:xfrm>
+          <a:prstGeom prst="rect">
+            <a:avLst/>
+          </a:prstGeom>
+        </p:spPr>
+      </p:pic>
+    </p:spTree>
+    <p:extLst>
+      <p:ext uri="{BB962C8B-B14F-4D97-AF65-F5344CB8AC3E}">
+        <p14:creationId xmlns:p14="http://schemas.microsoft.com/office/powerpoint/2010/main" val="644755747"/>
+      </p:ext>
+    </p:extLst>
+  </p:cSld>
+  <p:clrMapOvr>
+    <a:masterClrMapping/>
+  </p:clrMapOvr>
+</p:sld>
+</file>
+
+<file path=ppt/slides/slide9.xml><?xml version="1.0" encoding="utf-8"?>
+<p:sld xmlns:a="http://schemas.openxmlformats.org/drawingml/2006/main" xmlns:r="http://schemas.openxmlformats.org/officeDocument/2006/relationships" xmlns:p="http://schemas.openxmlformats.org/presentationml/2006/main">
+  <p:cSld>
+    <p:spTree>
+      <p:nvGrpSpPr>
+        <p:cNvPr id="1" name="">
+          <a:extLst>
+            <a:ext uri="{FF2B5EF4-FFF2-40B4-BE49-F238E27FC236}">
+              <a16:creationId xmlns:a16="http://schemas.microsoft.com/office/drawing/2014/main" id="{50AEBCC9-A10A-4349-0D90-CFC767DFD5C3}"/>
+            </a:ext>
+          </a:extLst>
+        </p:cNvPr>
+        <p:cNvGrpSpPr/>
+        <p:nvPr/>
+      </p:nvGrpSpPr>
+      <p:grpSpPr>
+        <a:xfrm>
+          <a:off x="0" y="0"/>
+          <a:ext cx="0" cy="0"/>
+          <a:chOff x="0" y="0"/>
+          <a:chExt cx="0" cy="0"/>
+        </a:xfrm>
+      </p:grpSpPr>
+      <p:sp>
+        <p:nvSpPr>
+          <p:cNvPr id="4" name="Title 1">
+            <a:extLst>
+              <a:ext uri="{FF2B5EF4-FFF2-40B4-BE49-F238E27FC236}">
+                <a16:creationId xmlns:a16="http://schemas.microsoft.com/office/drawing/2014/main" id="{2B6214D6-FE13-F250-3D10-88CAB2D5FB66}"/>
+              </a:ext>
+            </a:extLst>
+          </p:cNvPr>
+          <p:cNvSpPr>
+            <a:spLocks noGrp="1"/>
+          </p:cNvSpPr>
+          <p:nvPr>
+            <p:ph type="title"/>
+          </p:nvPr>
+        </p:nvSpPr>
+        <p:spPr>
+          <a:xfrm>
+            <a:off x="0" y="0"/>
+            <a:ext cx="10515600" cy="1325563"/>
+          </a:xfrm>
+        </p:spPr>
+        <p:txBody>
+          <a:bodyPr>
+            <a:normAutofit/>
+          </a:bodyPr>
+          <a:lstStyle/>
+          <a:p>
+            <a:r>
+              <a:rPr lang="en-US" sz="3200" dirty="0"/>
+              <a:t>Results – 0.6 noise (non-linear dynamics MPC)</a:t>
+            </a:r>
+          </a:p>
+        </p:txBody>
+      </p:sp>
+      <p:pic>
+        <p:nvPicPr>
+          <p:cNvPr id="5" name="Picture 4">
+            <a:extLst>
+              <a:ext uri="{FF2B5EF4-FFF2-40B4-BE49-F238E27FC236}">
+                <a16:creationId xmlns:a16="http://schemas.microsoft.com/office/drawing/2014/main" id="{5A3CD8E1-B74F-3A24-3C43-BB04979A990D}"/>
+              </a:ext>
+            </a:extLst>
+          </p:cNvPr>
+          <p:cNvPicPr>
+            <a:picLocks noChangeAspect="1"/>
+          </p:cNvPicPr>
+          <p:nvPr/>
+        </p:nvPicPr>
+        <p:blipFill>
+          <a:blip r:embed="rId2"/>
+          <a:stretch>
+            <a:fillRect/>
+          </a:stretch>
+        </p:blipFill>
+        <p:spPr>
+          <a:xfrm>
+            <a:off x="0" y="1661698"/>
+            <a:ext cx="12192000" cy="5196302"/>
+          </a:xfrm>
+          <a:prstGeom prst="rect">
+            <a:avLst/>
+          </a:prstGeom>
+        </p:spPr>
+      </p:pic>
+    </p:spTree>
+    <p:extLst>
+      <p:ext uri="{BB962C8B-B14F-4D97-AF65-F5344CB8AC3E}">
+        <p14:creationId xmlns:p14="http://schemas.microsoft.com/office/powerpoint/2010/main" val="3341038544"/>
       </p:ext>
     </p:extLst>
   </p:cSld>

</xml_diff>